<commit_message>
New Update from MarsCloud
</commit_message>
<xml_diff>
--- a/Target Folder/QA-Files/zh-CN/English File.pptx
+++ b/Target Folder/QA-Files/zh-CN/English File.pptx
@@ -9291,7 +9291,7 @@
             </a:pPr>
             <a:r>
               <a:rPr dirty="0"/>
-              <a:t>做得非常好</a:t>
+              <a:t>非常出色</a:t>
             </a:r>
           </a:p>
         </p:txBody>
@@ -9358,15 +9358,15 @@
             <a:pPr algn="just"/>
             <a:r>
               <a:rPr sz="1600" dirty="0"/>
-              <a:t> 客户非常重要，他们将永远被优先考虑。现在我深恶痛绝。这不是关于数量，而是关于巧克力的乐趣，以及我的员工做作业的乐趣。这就像一种不同的沙拉。根本没有航空公司，甚至连一点痕迹都没有。人生的痛苦有时会被谈论。我们与社区成员共同生活；我们的人生旅程是相同的。然而，Maecenas 不需要医疗护理。</a:t>
+              <a:t> 客户非常重要，他们将永远被优先考虑。现在我深恶痛绝。这不是关于数量，而是关于巧克力的乐趣，以及我的员工做作业的乐趣。这就像一种不同的沙拉。根本没有航空公司，甚至连一丝痕迹都没有。人生的痛苦有时会被谈及。我们与社区成员共同生活；我们的人生旅程是相同的。然而，Maecenas 不需要医疗护理。</a:t>
             </a:r>
             <a:r>
               <a:rPr sz="1600" dirty="0" err="1"/>
-              <a:t>毛里斯</a:t>
+              <a:t>Mauris</a:t>
             </a:r>
             <a:r>
               <a:rPr sz="1600" dirty="0"/>
-              <a:t>坚定、注重行动，不易动摇。但对于</a:t>
+              <a:t> 坚定、专注于行动，不易动摇。但对 </a:t>
             </a:r>
             <a:r>
               <a:rPr dirty="0"/>
@@ -9374,22 +9374,22 @@
             </a:r>
             <a:r>
               <a:rPr sz="1600" dirty="0"/>
-              <a:t>的承诺和持续的努力，务必保持谨慎；哀悼者不会奉承表演者。在提供财务自由之前完成任务。通往山谷没有平坦的道路，现在人生旅程清晰可见。你不需要迅速行动。Morbi 是一个</a:t>
+              <a:t> 的承诺和持续努力要始终保持谨慎；哀悼者不会奉承表演者。在提供财务自由之前完成任务。通往山谷没有平坦的道路，现在人生旅程清晰可见。你不需要迅速行动。Morbi 是一个 </a:t>
             </a:r>
             <a:r>
               <a:rPr/>
-              <a:t>不懈的@test.com </a:t>
+              <a:t>relentless@test.com </a:t>
             </a:r>
             <a:r>
               <a:rPr sz="1600" dirty="0"/>
-              <a:t>批评者，挑战的作者。疾病影响身体。目前没有目标。</a:t>
+              <a:t>的评论家，是挑战的作者。疾病影响身体。目前没有目标。</a:t>
             </a:r>
           </a:p>
           <a:p>
             <a:pPr algn="just"/>
             <a:r>
               <a:rPr sz="1600" dirty="0"/>
-              <a:t> Maecenas 坚定不移，轻松应对挑战，但却奉承土地。Maecenas 尚不知道该投资哪块土地。没有什么是容易的。Aenean 的作业说明了一切。它来自毛里。现在，专注并不能让生活变得轻松，过去的挣扎也无法决定未来。无论是来自网络还是员工，病态的玩笑总是能被听到。Maecenas 的精心策划被证明是高效的，持续的推进</a:t>
+              <a:t> Maecenas 坚定不移，轻松应对挑战，却又奉承这片土地。Maecenas 尚不知道该投资哪片土地。没有什么事是容易的。Aenean 的作业说明了一切。它来自 Mauri。现在，专注并不能让生活变得轻松，过去的挣扎也不能决定未来。无论是来自网络还是员工，病态的玩笑总是萦绕耳边。Maecenas 精心的规划证明是高效的，持续的推进 </a:t>
             </a:r>
             <a:r>
               <a:rPr dirty="0"/>
@@ -9397,7 +9397,7 @@
             </a:r>
             <a:r>
               <a:rPr sz="1600" dirty="0"/>
-              <a:t>不留任何退路。</a:t>
+              <a:t> 不留退路。</a:t>
             </a:r>
           </a:p>
         </p:txBody>
@@ -10408,7 +10408,7 @@
                           <a:latin typeface="Arial" panose="020B0604020202020204" pitchFamily="34" charset="0"/>
                           <a:cs typeface="Droid Sans Fallback" charset="0"/>
                         </a:rPr>
-                        <a:t>第 1 列</a:t>
+                        <a:t>第一列</a:t>
                       </a:r>
                     </a:p>
                   </a:txBody>
@@ -10857,7 +10857,7 @@
                           <a:latin typeface="Arial" panose="020B0604020202020204" pitchFamily="34" charset="0"/>
                           <a:cs typeface="DejaVu Sans" charset="0"/>
                         </a:rPr>
-                        <a:t>第 2 列</a:t>
+                        <a:t>第二列</a:t>
                       </a:r>
                     </a:p>
                   </a:txBody>
@@ -11306,7 +11306,7 @@
                           <a:latin typeface="Arial" panose="020B0604020202020204" pitchFamily="34" charset="0"/>
                           <a:cs typeface="DejaVu Sans" charset="0"/>
                         </a:rPr>
-                        <a:t>第 3 列</a:t>
+                        <a:t>第三列</a:t>
                       </a:r>
                     </a:p>
                   </a:txBody>
@@ -11755,7 +11755,7 @@
                           <a:latin typeface="Arial" panose="020B0604020202020204" pitchFamily="34" charset="0"/>
                           <a:cs typeface="DejaVu Sans" charset="0"/>
                         </a:rPr>
-                        <a:t>第 4 列</a:t>
+                        <a:t>第四列</a:t>
                       </a:r>
                     </a:p>
                   </a:txBody>
@@ -12204,7 +12204,7 @@
                           <a:latin typeface="Arial" panose="020B0604020202020204" pitchFamily="34" charset="0"/>
                           <a:cs typeface="DejaVu Sans" charset="0"/>
                         </a:rPr>
-                        <a:t>第 5 列</a:t>
+                        <a:t>第五列</a:t>
                       </a:r>
                     </a:p>
                     <a:p>

</xml_diff>